<commit_message>
UI: Embed real ABLE website homepage screen into mobile prototype slide
</commit_message>
<xml_diff>
--- a/ABLE_Two_New_Slides.pptx
+++ b/ABLE_Two_New_Slides.pptx
@@ -3927,7 +3927,7 @@
         <p:spPr>
           <a:xfrm>
             <a:off x="731520" y="1600200"/>
-            <a:ext cx="3291840" cy="4297680"/>
+            <a:ext cx="3108960" cy="4389120"/>
           </a:xfrm>
           <a:prstGeom prst="roundRect">
             <a:avLst/>
@@ -3935,9 +3935,9 @@
           <a:solidFill>
             <a:srgbClr val="FFFFFF"/>
           </a:solidFill>
-          <a:ln w="25400">
+          <a:ln w="31750">
             <a:solidFill>
-              <a:srgbClr val="B8C5D0"/>
+              <a:srgbClr val="0F2D45"/>
             </a:solidFill>
           </a:ln>
         </p:spPr>
@@ -3971,8 +3971,8 @@
         </p:nvSpPr>
         <p:spPr>
           <a:xfrm>
-            <a:off x="2011680" y="1737360"/>
-            <a:ext cx="731520" cy="64008"/>
+            <a:off x="1920240" y="1719072"/>
+            <a:ext cx="731520" cy="54864"/>
           </a:xfrm>
           <a:prstGeom prst="roundRect">
             <a:avLst/>
@@ -4008,16 +4008,40 @@
           </a:p>
         </p:txBody>
       </p:sp>
-      <p:sp>
-        <p:nvSpPr>
-          <p:cNvPr id="7" name="TextBox 6"/>
+      <p:pic>
+        <p:nvPicPr>
+          <p:cNvPr id="7" name="Picture 6" descr="site_phone_screen.png"/>
+          <p:cNvPicPr>
+            <a:picLocks noChangeAspect="1"/>
+          </p:cNvPicPr>
+          <p:nvPr/>
+        </p:nvPicPr>
+        <p:blipFill>
+          <a:blip r:embed="rId2"/>
+          <a:stretch>
+            <a:fillRect/>
+          </a:stretch>
+        </p:blipFill>
+        <p:spPr>
+          <a:xfrm>
+            <a:off x="868680" y="1847088"/>
+            <a:ext cx="2834640" cy="4023360"/>
+          </a:xfrm>
+          <a:prstGeom prst="rect">
+            <a:avLst/>
+          </a:prstGeom>
+        </p:spPr>
+      </p:pic>
+      <p:sp>
+        <p:nvSpPr>
+          <p:cNvPr id="8" name="TextBox 7"/>
           <p:cNvSpPr txBox="1"/>
           <p:nvPr/>
         </p:nvSpPr>
         <p:spPr>
           <a:xfrm>
-            <a:off x="822960" y="1920240"/>
-            <a:ext cx="3108960" cy="914400"/>
+            <a:off x="731520" y="5989320"/>
+            <a:ext cx="3291840" cy="274320"/>
           </a:xfrm>
           <a:prstGeom prst="rect">
             <a:avLst/>
@@ -4025,71 +4049,179 @@
           <a:noFill/>
         </p:spPr>
         <p:txBody>
+          <a:bodyPr wrap="none">
+            <a:spAutoFit/>
+          </a:bodyPr>
+          <a:lstStyle/>
+          <a:p>
+            <a:pPr>
+              <a:defRPr sz="850" i="1">
+                <a:solidFill>
+                  <a:srgbClr val="5E6B75"/>
+                </a:solidFill>
+              </a:defRPr>
+            </a:pPr>
+            <a:r>
+              <a:t>Live production interface — ABLE Accessibility &amp; Inclusion Platform.</a:t>
+            </a:r>
+          </a:p>
+        </p:txBody>
+      </p:sp>
+      <p:sp>
+        <p:nvSpPr>
+          <p:cNvPr id="9" name="TextBox 8"/>
+          <p:cNvSpPr txBox="1"/>
+          <p:nvPr/>
+        </p:nvSpPr>
+        <p:spPr>
+          <a:xfrm>
+            <a:off x="4206240" y="1600200"/>
+            <a:ext cx="7223760" cy="4297680"/>
+          </a:xfrm>
+          <a:prstGeom prst="rect">
+            <a:avLst/>
+          </a:prstGeom>
+          <a:noFill/>
+        </p:spPr>
+        <p:txBody>
           <a:bodyPr wrap="square">
             <a:spAutoFit/>
           </a:bodyPr>
           <a:lstStyle/>
           <a:p>
-            <a:pPr algn="ctr">
-              <a:defRPr sz="2200" b="1">
-                <a:solidFill>
-                  <a:srgbClr val="0F2D45"/>
+            <a:pPr>
+              <a:spcAft>
+                <a:spcPts val="1400"/>
+              </a:spcAft>
+              <a:defRPr sz="1400" b="1">
+                <a:solidFill>
+                  <a:srgbClr val="2878C8"/>
                 </a:solidFill>
                 <a:latin typeface="Aptos Display"/>
               </a:defRPr>
             </a:pPr>
             <a:r>
-              <a:t>ABLE</a:t>
-            </a:r>
-          </a:p>
-          <a:p>
-            <a:pPr algn="ctr">
-              <a:defRPr sz="1050" b="1">
-                <a:solidFill>
-                  <a:srgbClr val="2878C8"/>
+              <a:t>PROTOTYPE FOCUS</a:t>
+            </a:r>
+          </a:p>
+          <a:p>
+            <a:pPr>
+              <a:spcAft>
+                <a:spcPts val="1200"/>
+              </a:spcAft>
+              <a:defRPr sz="1300">
+                <a:solidFill>
+                  <a:srgbClr val="202A33"/>
                 </a:solidFill>
                 <a:latin typeface="Aptos Display"/>
               </a:defRPr>
             </a:pPr>
             <a:r>
-              <a:t>Empowering Accessibility &amp; Inclusion</a:t>
-            </a:r>
-          </a:p>
-          <a:p>
-            <a:pPr algn="ctr">
-              <a:defRPr sz="950">
-                <a:solidFill>
-                  <a:srgbClr val="5E6B75"/>
+              <a:t>•  Simple navigation and prominent, high-contrast primary actions</a:t>
+            </a:r>
+          </a:p>
+          <a:p>
+            <a:pPr>
+              <a:spcAft>
+                <a:spcPts val="1200"/>
+              </a:spcAft>
+              <a:defRPr sz="1300">
+                <a:solidFill>
+                  <a:srgbClr val="202A33"/>
                 </a:solidFill>
                 <a:latin typeface="Aptos Display"/>
               </a:defRPr>
             </a:pPr>
             <a:r>
-              <a:t>Assistance, barrier reporting, and resources in one place.</a:t>
-            </a:r>
-          </a:p>
-        </p:txBody>
-      </p:sp>
-      <p:sp>
-        <p:nvSpPr>
-          <p:cNvPr id="8" name="Rounded Rectangle 7"/>
+              <a:t>•  Clear pathways to physical assistance, barrier reporting, and accessible facilities</a:t>
+            </a:r>
+          </a:p>
+          <a:p>
+            <a:pPr>
+              <a:spcAft>
+                <a:spcPts val="1200"/>
+              </a:spcAft>
+              <a:defRPr sz="1300">
+                <a:solidFill>
+                  <a:srgbClr val="202A33"/>
+                </a:solidFill>
+                <a:latin typeface="Aptos Display"/>
+              </a:defRPr>
+            </a:pPr>
+            <a:r>
+              <a:t>•  Mobile-friendly, responsive layout adhering strictly to WCAG touch standards (44px+)</a:t>
+            </a:r>
+          </a:p>
+          <a:p>
+            <a:pPr>
+              <a:spcAft>
+                <a:spcPts val="1200"/>
+              </a:spcAft>
+              <a:defRPr sz="1300">
+                <a:solidFill>
+                  <a:srgbClr val="202A33"/>
+                </a:solidFill>
+                <a:latin typeface="Aptos Display"/>
+              </a:defRPr>
+            </a:pPr>
+            <a:r>
+              <a:t>•  Short, accessible labels paired with assistive screen-reader and voice support</a:t>
+            </a:r>
+          </a:p>
+          <a:p>
+            <a:pPr>
+              <a:spcAft>
+                <a:spcPts val="1200"/>
+              </a:spcAft>
+              <a:defRPr sz="1300">
+                <a:solidFill>
+                  <a:srgbClr val="202A33"/>
+                </a:solidFill>
+                <a:latin typeface="Aptos Display"/>
+              </a:defRPr>
+            </a:pPr>
+            <a:r>
+              <a:t>•  Guides users toward a clear, friction-free next step with zero cognitive overload</a:t>
+            </a:r>
+          </a:p>
+          <a:p>
+            <a:pPr>
+              <a:spcAft>
+                <a:spcPts val="1200"/>
+              </a:spcAft>
+              <a:defRPr sz="1300">
+                <a:solidFill>
+                  <a:srgbClr val="202A33"/>
+                </a:solidFill>
+                <a:latin typeface="Aptos Display"/>
+              </a:defRPr>
+            </a:pPr>
+            <a:r>
+              <a:t>•  Live volunteer dispatcher with Leaflet.js interactive maps and verified NSS student profiles</a:t>
+            </a:r>
+          </a:p>
+        </p:txBody>
+      </p:sp>
+      <p:sp>
+        <p:nvSpPr>
+          <p:cNvPr id="10" name="Rectangle 9"/>
           <p:cNvSpPr/>
           <p:nvPr/>
         </p:nvSpPr>
         <p:spPr>
           <a:xfrm>
-            <a:off x="1005840" y="2926080"/>
-            <a:ext cx="2743200" cy="475488"/>
-          </a:xfrm>
-          <a:prstGeom prst="roundRect">
+            <a:off x="731520" y="6217920"/>
+            <a:ext cx="10698480" cy="9144"/>
+          </a:xfrm>
+          <a:prstGeom prst="rect">
             <a:avLst/>
           </a:prstGeom>
           <a:solidFill>
-            <a:srgbClr val="0F2D45"/>
+            <a:srgbClr val="D7E5F2"/>
           </a:solidFill>
           <a:ln>
             <a:solidFill>
-              <a:srgbClr val="0F2D45"/>
+              <a:srgbClr val="D7E5F2"/>
             </a:solidFill>
           </a:ln>
         </p:spPr>
@@ -4111,260 +4243,20 @@
           <a:bodyPr rtlCol="0" anchor="ctr"/>
           <a:lstStyle/>
           <a:p>
-            <a:pPr algn="ctr">
-              <a:defRPr b="1" sz="1100">
-                <a:solidFill>
-                  <a:srgbClr val="FFFFFF"/>
-                </a:solidFill>
-              </a:defRPr>
-            </a:pPr>
-            <a:r>
-              <a:t>GET ASSISTANCE</a:t>
-            </a:r>
-          </a:p>
-        </p:txBody>
-      </p:sp>
-      <p:sp>
-        <p:nvSpPr>
-          <p:cNvPr id="9" name="Rounded Rectangle 8"/>
-          <p:cNvSpPr/>
-          <p:nvPr/>
-        </p:nvSpPr>
-        <p:spPr>
-          <a:xfrm>
-            <a:off x="1005840" y="3520440"/>
-            <a:ext cx="2743200" cy="475488"/>
-          </a:xfrm>
-          <a:prstGeom prst="roundRect">
-            <a:avLst/>
-          </a:prstGeom>
-          <a:solidFill>
-            <a:srgbClr val="2878C8"/>
-          </a:solidFill>
-          <a:ln>
-            <a:solidFill>
-              <a:srgbClr val="2878C8"/>
-            </a:solidFill>
-          </a:ln>
-        </p:spPr>
-        <p:style>
-          <a:lnRef idx="1">
-            <a:schemeClr val="accent1"/>
-          </a:lnRef>
-          <a:fillRef idx="3">
-            <a:schemeClr val="accent1"/>
-          </a:fillRef>
-          <a:effectRef idx="2">
-            <a:schemeClr val="accent1"/>
-          </a:effectRef>
-          <a:fontRef idx="minor">
-            <a:schemeClr val="lt1"/>
-          </a:fontRef>
-        </p:style>
-        <p:txBody>
-          <a:bodyPr rtlCol="0" anchor="ctr"/>
-          <a:lstStyle/>
-          <a:p>
-            <a:pPr algn="ctr">
-              <a:defRPr b="1" sz="1100">
-                <a:solidFill>
-                  <a:srgbClr val="FFFFFF"/>
-                </a:solidFill>
-              </a:defRPr>
-            </a:pPr>
-            <a:r>
-              <a:t>REPORT A BARRIER</a:t>
-            </a:r>
-          </a:p>
-        </p:txBody>
-      </p:sp>
-      <p:sp>
-        <p:nvSpPr>
-          <p:cNvPr id="10" name="Rounded Rectangle 9"/>
-          <p:cNvSpPr/>
-          <p:nvPr/>
-        </p:nvSpPr>
-        <p:spPr>
-          <a:xfrm>
-            <a:off x="1005840" y="4160520"/>
-            <a:ext cx="850392" cy="640080"/>
-          </a:xfrm>
-          <a:prstGeom prst="roundRect">
-            <a:avLst/>
-          </a:prstGeom>
-          <a:solidFill>
-            <a:srgbClr val="F6F9FC"/>
-          </a:solidFill>
-          <a:ln>
-            <a:solidFill>
-              <a:srgbClr val="D7E5F2"/>
-            </a:solidFill>
-          </a:ln>
-        </p:spPr>
-        <p:style>
-          <a:lnRef idx="1">
-            <a:schemeClr val="accent1"/>
-          </a:lnRef>
-          <a:fillRef idx="3">
-            <a:schemeClr val="accent1"/>
-          </a:fillRef>
-          <a:effectRef idx="2">
-            <a:schemeClr val="accent1"/>
-          </a:effectRef>
-          <a:fontRef idx="minor">
-            <a:schemeClr val="lt1"/>
-          </a:fontRef>
-        </p:style>
-        <p:txBody>
-          <a:bodyPr rtlCol="0" anchor="ctr"/>
-          <a:lstStyle/>
-          <a:p>
-            <a:pPr algn="ctr">
-              <a:defRPr sz="850" b="1">
-                <a:solidFill>
-                  <a:srgbClr val="202A33"/>
-                </a:solidFill>
-                <a:latin typeface="Aptos Display"/>
-              </a:defRPr>
-            </a:pPr>
-            <a:r>
-              <a:t>Emergency</a:t>
-            </a:r>
-            <a:br/>
-            <a:r>
-              <a:t>SOS</a:t>
-            </a:r>
-          </a:p>
-        </p:txBody>
-      </p:sp>
-      <p:sp>
-        <p:nvSpPr>
-          <p:cNvPr id="11" name="Rounded Rectangle 10"/>
-          <p:cNvSpPr/>
-          <p:nvPr/>
-        </p:nvSpPr>
-        <p:spPr>
-          <a:xfrm>
-            <a:off x="1947672" y="4160520"/>
-            <a:ext cx="850392" cy="640080"/>
-          </a:xfrm>
-          <a:prstGeom prst="roundRect">
-            <a:avLst/>
-          </a:prstGeom>
-          <a:solidFill>
-            <a:srgbClr val="F6F9FC"/>
-          </a:solidFill>
-          <a:ln>
-            <a:solidFill>
-              <a:srgbClr val="D7E5F2"/>
-            </a:solidFill>
-          </a:ln>
-        </p:spPr>
-        <p:style>
-          <a:lnRef idx="1">
-            <a:schemeClr val="accent1"/>
-          </a:lnRef>
-          <a:fillRef idx="3">
-            <a:schemeClr val="accent1"/>
-          </a:fillRef>
-          <a:effectRef idx="2">
-            <a:schemeClr val="accent1"/>
-          </a:effectRef>
-          <a:fontRef idx="minor">
-            <a:schemeClr val="lt1"/>
-          </a:fontRef>
-        </p:style>
-        <p:txBody>
-          <a:bodyPr rtlCol="0" anchor="ctr"/>
-          <a:lstStyle/>
-          <a:p>
-            <a:pPr algn="ctr">
-              <a:defRPr sz="850" b="1">
-                <a:solidFill>
-                  <a:srgbClr val="202A33"/>
-                </a:solidFill>
-                <a:latin typeface="Aptos Display"/>
-              </a:defRPr>
-            </a:pPr>
-            <a:r>
-              <a:t>Accessible</a:t>
-            </a:r>
-            <a:br/>
-            <a:r>
-              <a:t>Directory</a:t>
-            </a:r>
-          </a:p>
-        </p:txBody>
-      </p:sp>
-      <p:sp>
-        <p:nvSpPr>
-          <p:cNvPr id="12" name="Rounded Rectangle 11"/>
-          <p:cNvSpPr/>
-          <p:nvPr/>
-        </p:nvSpPr>
-        <p:spPr>
-          <a:xfrm>
-            <a:off x="2889504" y="4160520"/>
-            <a:ext cx="850392" cy="640080"/>
-          </a:xfrm>
-          <a:prstGeom prst="roundRect">
-            <a:avLst/>
-          </a:prstGeom>
-          <a:solidFill>
-            <a:srgbClr val="F6F9FC"/>
-          </a:solidFill>
-          <a:ln>
-            <a:solidFill>
-              <a:srgbClr val="D7E5F2"/>
-            </a:solidFill>
-          </a:ln>
-        </p:spPr>
-        <p:style>
-          <a:lnRef idx="1">
-            <a:schemeClr val="accent1"/>
-          </a:lnRef>
-          <a:fillRef idx="3">
-            <a:schemeClr val="accent1"/>
-          </a:fillRef>
-          <a:effectRef idx="2">
-            <a:schemeClr val="accent1"/>
-          </a:effectRef>
-          <a:fontRef idx="minor">
-            <a:schemeClr val="lt1"/>
-          </a:fontRef>
-        </p:style>
-        <p:txBody>
-          <a:bodyPr rtlCol="0" anchor="ctr"/>
-          <a:lstStyle/>
-          <a:p>
-            <a:pPr algn="ctr">
-              <a:defRPr sz="850" b="1">
-                <a:solidFill>
-                  <a:srgbClr val="202A33"/>
-                </a:solidFill>
-                <a:latin typeface="Aptos Display"/>
-              </a:defRPr>
-            </a:pPr>
-            <a:r>
-              <a:t>Volunteer</a:t>
-            </a:r>
-            <a:br/>
-            <a:r>
-              <a:t>Network</a:t>
-            </a:r>
-          </a:p>
-        </p:txBody>
-      </p:sp>
-      <p:sp>
-        <p:nvSpPr>
-          <p:cNvPr id="13" name="TextBox 12"/>
+            <a:pPr algn="ctr"/>
+          </a:p>
+        </p:txBody>
+      </p:sp>
+      <p:sp>
+        <p:nvSpPr>
+          <p:cNvPr id="11" name="TextBox 10"/>
           <p:cNvSpPr txBox="1"/>
           <p:nvPr/>
         </p:nvSpPr>
         <p:spPr>
           <a:xfrm>
-            <a:off x="731520" y="5897880"/>
-            <a:ext cx="3291840" cy="274320"/>
+            <a:off x="731520" y="6263640"/>
+            <a:ext cx="4572000" cy="320040"/>
           </a:xfrm>
           <a:prstGeom prst="rect">
             <a:avLst/>
@@ -4378,228 +4270,13 @@
           <a:lstStyle/>
           <a:p>
             <a:pPr>
-              <a:defRPr sz="850" i="1">
+              <a:defRPr sz="1000">
                 <a:solidFill>
                   <a:srgbClr val="5E6B75"/>
                 </a:solidFill>
               </a:defRPr>
             </a:pPr>
             <a:r>
-              <a:t>Illustrative concept — backed by live Python Flask &amp; SQLite.</a:t>
-            </a:r>
-          </a:p>
-        </p:txBody>
-      </p:sp>
-      <p:sp>
-        <p:nvSpPr>
-          <p:cNvPr id="14" name="TextBox 13"/>
-          <p:cNvSpPr txBox="1"/>
-          <p:nvPr/>
-        </p:nvSpPr>
-        <p:spPr>
-          <a:xfrm>
-            <a:off x="4389120" y="1600200"/>
-            <a:ext cx="7040880" cy="4297680"/>
-          </a:xfrm>
-          <a:prstGeom prst="rect">
-            <a:avLst/>
-          </a:prstGeom>
-          <a:noFill/>
-        </p:spPr>
-        <p:txBody>
-          <a:bodyPr wrap="square">
-            <a:spAutoFit/>
-          </a:bodyPr>
-          <a:lstStyle/>
-          <a:p>
-            <a:pPr>
-              <a:spcAft>
-                <a:spcPts val="1400"/>
-              </a:spcAft>
-              <a:defRPr sz="1400" b="1">
-                <a:solidFill>
-                  <a:srgbClr val="2878C8"/>
-                </a:solidFill>
-                <a:latin typeface="Aptos Display"/>
-              </a:defRPr>
-            </a:pPr>
-            <a:r>
-              <a:t>PROTOTYPE FOCUS</a:t>
-            </a:r>
-          </a:p>
-          <a:p>
-            <a:pPr>
-              <a:spcAft>
-                <a:spcPts val="1200"/>
-              </a:spcAft>
-              <a:defRPr sz="1300">
-                <a:solidFill>
-                  <a:srgbClr val="202A33"/>
-                </a:solidFill>
-                <a:latin typeface="Aptos Display"/>
-              </a:defRPr>
-            </a:pPr>
-            <a:r>
-              <a:t>•  Simple navigation and prominent, high-contrast primary actions</a:t>
-            </a:r>
-          </a:p>
-          <a:p>
-            <a:pPr>
-              <a:spcAft>
-                <a:spcPts val="1200"/>
-              </a:spcAft>
-              <a:defRPr sz="1300">
-                <a:solidFill>
-                  <a:srgbClr val="202A33"/>
-                </a:solidFill>
-                <a:latin typeface="Aptos Display"/>
-              </a:defRPr>
-            </a:pPr>
-            <a:r>
-              <a:t>•  Clear pathways to physical assistance, barrier reporting, and accessible facilities</a:t>
-            </a:r>
-          </a:p>
-          <a:p>
-            <a:pPr>
-              <a:spcAft>
-                <a:spcPts val="1200"/>
-              </a:spcAft>
-              <a:defRPr sz="1300">
-                <a:solidFill>
-                  <a:srgbClr val="202A33"/>
-                </a:solidFill>
-                <a:latin typeface="Aptos Display"/>
-              </a:defRPr>
-            </a:pPr>
-            <a:r>
-              <a:t>•  Mobile-friendly, responsive layout adhering strictly to WCAG touch standards (44px+)</a:t>
-            </a:r>
-          </a:p>
-          <a:p>
-            <a:pPr>
-              <a:spcAft>
-                <a:spcPts val="1200"/>
-              </a:spcAft>
-              <a:defRPr sz="1300">
-                <a:solidFill>
-                  <a:srgbClr val="202A33"/>
-                </a:solidFill>
-                <a:latin typeface="Aptos Display"/>
-              </a:defRPr>
-            </a:pPr>
-            <a:r>
-              <a:t>•  Short, accessible labels paired with assistive screen-reader and voice support</a:t>
-            </a:r>
-          </a:p>
-          <a:p>
-            <a:pPr>
-              <a:spcAft>
-                <a:spcPts val="1200"/>
-              </a:spcAft>
-              <a:defRPr sz="1300">
-                <a:solidFill>
-                  <a:srgbClr val="202A33"/>
-                </a:solidFill>
-                <a:latin typeface="Aptos Display"/>
-              </a:defRPr>
-            </a:pPr>
-            <a:r>
-              <a:t>•  Guides users toward a clear, friction-free next step with zero cognitive overload</a:t>
-            </a:r>
-          </a:p>
-          <a:p>
-            <a:pPr>
-              <a:spcAft>
-                <a:spcPts val="1200"/>
-              </a:spcAft>
-              <a:defRPr sz="1300">
-                <a:solidFill>
-                  <a:srgbClr val="202A33"/>
-                </a:solidFill>
-                <a:latin typeface="Aptos Display"/>
-              </a:defRPr>
-            </a:pPr>
-            <a:r>
-              <a:t>•  Live volunteer dispatcher with Leaflet.js interactive maps and verified NSS student profiles</a:t>
-            </a:r>
-          </a:p>
-        </p:txBody>
-      </p:sp>
-      <p:sp>
-        <p:nvSpPr>
-          <p:cNvPr id="15" name="Rectangle 14"/>
-          <p:cNvSpPr/>
-          <p:nvPr/>
-        </p:nvSpPr>
-        <p:spPr>
-          <a:xfrm>
-            <a:off x="731520" y="6217920"/>
-            <a:ext cx="10698480" cy="9144"/>
-          </a:xfrm>
-          <a:prstGeom prst="rect">
-            <a:avLst/>
-          </a:prstGeom>
-          <a:solidFill>
-            <a:srgbClr val="D7E5F2"/>
-          </a:solidFill>
-          <a:ln>
-            <a:solidFill>
-              <a:srgbClr val="D7E5F2"/>
-            </a:solidFill>
-          </a:ln>
-        </p:spPr>
-        <p:style>
-          <a:lnRef idx="1">
-            <a:schemeClr val="accent1"/>
-          </a:lnRef>
-          <a:fillRef idx="3">
-            <a:schemeClr val="accent1"/>
-          </a:fillRef>
-          <a:effectRef idx="2">
-            <a:schemeClr val="accent1"/>
-          </a:effectRef>
-          <a:fontRef idx="minor">
-            <a:schemeClr val="lt1"/>
-          </a:fontRef>
-        </p:style>
-        <p:txBody>
-          <a:bodyPr rtlCol="0" anchor="ctr"/>
-          <a:lstStyle/>
-          <a:p>
-            <a:pPr algn="ctr"/>
-          </a:p>
-        </p:txBody>
-      </p:sp>
-      <p:sp>
-        <p:nvSpPr>
-          <p:cNvPr id="16" name="TextBox 15"/>
-          <p:cNvSpPr txBox="1"/>
-          <p:nvPr/>
-        </p:nvSpPr>
-        <p:spPr>
-          <a:xfrm>
-            <a:off x="731520" y="6263640"/>
-            <a:ext cx="4572000" cy="320040"/>
-          </a:xfrm>
-          <a:prstGeom prst="rect">
-            <a:avLst/>
-          </a:prstGeom>
-          <a:noFill/>
-        </p:spPr>
-        <p:txBody>
-          <a:bodyPr wrap="none">
-            <a:spAutoFit/>
-          </a:bodyPr>
-          <a:lstStyle/>
-          <a:p>
-            <a:pPr>
-              <a:defRPr sz="1000">
-                <a:solidFill>
-                  <a:srgbClr val="5E6B75"/>
-                </a:solidFill>
-              </a:defRPr>
-            </a:pPr>
-            <a:r>
               <a:t>ABLE Platform • User-Facing Design</a:t>
             </a:r>
           </a:p>
@@ -4607,7 +4284,7 @@
       </p:sp>
       <p:sp>
         <p:nvSpPr>
-          <p:cNvPr id="17" name="TextBox 16"/>
+          <p:cNvPr id="12" name="TextBox 11"/>
           <p:cNvSpPr txBox="1"/>
           <p:nvPr/>
         </p:nvSpPr>

</xml_diff>

<commit_message>
Docs: Add 2 representative high-resolution code snapshots for project report
</commit_message>
<xml_diff>
--- a/ABLE_Two_New_Slides.pptx
+++ b/ABLE_Two_New_Slides.pptx
@@ -5,10 +5,10 @@
     <p:sldMasterId id="2147483648" r:id="rId1"/>
   </p:sldMasterIdLst>
   <p:sldIdLst>
-    <p:sldId id="256" r:id="rId7"/>
-    <p:sldId id="257" r:id="rId8"/>
+    <p:sldId id="256" r:id="rId2"/>
+    <p:sldId id="257" r:id="rId3"/>
   </p:sldIdLst>
-  <p:sldSz cx="12191695" cy="6858000" type="screen4x3"/>
+  <p:sldSz cx="12192000" cy="6858000"/>
   <p:notesSz cx="6858000" cy="9144000"/>
   <p:defaultTextStyle>
     <a:defPPr>
@@ -105,6 +105,22 @@
       </a:defRPr>
     </a:lvl9pPr>
   </p:defaultTextStyle>
+  <p:extLst>
+    <p:ext uri="{EFAFB233-063F-42B5-8137-9DF3F51BA10A}">
+      <p15:sldGuideLst xmlns:p15="http://schemas.microsoft.com/office/powerpoint/2012/main">
+        <p15:guide id="1" orient="horz" pos="2160">
+          <p15:clr>
+            <a:srgbClr val="A4A3A4"/>
+          </p15:clr>
+        </p15:guide>
+        <p15:guide id="2" pos="2880">
+          <p15:clr>
+            <a:srgbClr val="A4A3A4"/>
+          </p15:clr>
+        </p15:guide>
+      </p15:sldGuideLst>
+    </p:ext>
+  </p:extLst>
 </p:presentation>
 </file>
 
@@ -146,10 +162,9 @@
           <a:lstStyle/>
           <a:p>
             <a:r>
-              <a:rPr lang="en-US" smtClean="0"/>
+              <a:rPr lang="en-US"/>
               <a:t>Click to edit Master title style</a:t>
             </a:r>
-            <a:endParaRPr lang="en-US"/>
           </a:p>
         </p:txBody>
       </p:sp>
@@ -265,10 +280,9 @@
           </a:lstStyle>
           <a:p>
             <a:r>
-              <a:rPr lang="en-US" smtClean="0"/>
+              <a:rPr lang="en-US"/>
               <a:t>Click to edit Master subtitle style</a:t>
             </a:r>
-            <a:endParaRPr lang="en-US"/>
           </a:p>
         </p:txBody>
       </p:sp>
@@ -289,7 +303,7 @@
           <a:p>
             <a:fld id="{5BCAD085-E8A6-8845-BD4E-CB4CCA059FC4}" type="datetimeFigureOut">
               <a:rPr lang="en-US" smtClean="0"/>
-              <a:t>1/27/13</a:t>
+              <a:t>10/21/2026</a:t>
             </a:fld>
             <a:endParaRPr lang="en-US"/>
           </a:p>
@@ -383,10 +397,9 @@
           <a:lstStyle/>
           <a:p>
             <a:r>
-              <a:rPr lang="en-US" smtClean="0"/>
+              <a:rPr lang="en-US"/>
               <a:t>Click to edit Master title style</a:t>
             </a:r>
-            <a:endParaRPr lang="en-US"/>
           </a:p>
         </p:txBody>
       </p:sp>
@@ -407,38 +420,37 @@
           <a:p>
             <a:pPr lvl="0"/>
             <a:r>
-              <a:rPr lang="en-US" smtClean="0"/>
+              <a:rPr lang="en-US"/>
               <a:t>Click to edit Master text styles</a:t>
             </a:r>
           </a:p>
           <a:p>
             <a:pPr lvl="1"/>
             <a:r>
-              <a:rPr lang="en-US" smtClean="0"/>
+              <a:rPr lang="en-US"/>
               <a:t>Second level</a:t>
             </a:r>
           </a:p>
           <a:p>
             <a:pPr lvl="2"/>
             <a:r>
-              <a:rPr lang="en-US" smtClean="0"/>
+              <a:rPr lang="en-US"/>
               <a:t>Third level</a:t>
             </a:r>
           </a:p>
           <a:p>
             <a:pPr lvl="3"/>
             <a:r>
-              <a:rPr lang="en-US" smtClean="0"/>
+              <a:rPr lang="en-US"/>
               <a:t>Fourth level</a:t>
             </a:r>
           </a:p>
           <a:p>
             <a:pPr lvl="4"/>
             <a:r>
-              <a:rPr lang="en-US" smtClean="0"/>
+              <a:rPr lang="en-US"/>
               <a:t>Fifth level</a:t>
             </a:r>
-            <a:endParaRPr lang="en-US"/>
           </a:p>
         </p:txBody>
       </p:sp>
@@ -459,7 +471,7 @@
           <a:p>
             <a:fld id="{5BCAD085-E8A6-8845-BD4E-CB4CCA059FC4}" type="datetimeFigureOut">
               <a:rPr lang="en-US" smtClean="0"/>
-              <a:t>1/27/13</a:t>
+              <a:t>10/21/2026</a:t>
             </a:fld>
             <a:endParaRPr lang="en-US"/>
           </a:p>
@@ -558,10 +570,9 @@
           <a:lstStyle/>
           <a:p>
             <a:r>
-              <a:rPr lang="en-US" smtClean="0"/>
+              <a:rPr lang="en-US"/>
               <a:t>Click to edit Master title style</a:t>
             </a:r>
-            <a:endParaRPr lang="en-US"/>
           </a:p>
         </p:txBody>
       </p:sp>
@@ -587,38 +598,37 @@
           <a:p>
             <a:pPr lvl="0"/>
             <a:r>
-              <a:rPr lang="en-US" smtClean="0"/>
+              <a:rPr lang="en-US"/>
               <a:t>Click to edit Master text styles</a:t>
             </a:r>
           </a:p>
           <a:p>
             <a:pPr lvl="1"/>
             <a:r>
-              <a:rPr lang="en-US" smtClean="0"/>
+              <a:rPr lang="en-US"/>
               <a:t>Second level</a:t>
             </a:r>
           </a:p>
           <a:p>
             <a:pPr lvl="2"/>
             <a:r>
-              <a:rPr lang="en-US" smtClean="0"/>
+              <a:rPr lang="en-US"/>
               <a:t>Third level</a:t>
             </a:r>
           </a:p>
           <a:p>
             <a:pPr lvl="3"/>
             <a:r>
-              <a:rPr lang="en-US" smtClean="0"/>
+              <a:rPr lang="en-US"/>
               <a:t>Fourth level</a:t>
             </a:r>
           </a:p>
           <a:p>
             <a:pPr lvl="4"/>
             <a:r>
-              <a:rPr lang="en-US" smtClean="0"/>
+              <a:rPr lang="en-US"/>
               <a:t>Fifth level</a:t>
             </a:r>
-            <a:endParaRPr lang="en-US"/>
           </a:p>
         </p:txBody>
       </p:sp>
@@ -639,7 +649,7 @@
           <a:p>
             <a:fld id="{5BCAD085-E8A6-8845-BD4E-CB4CCA059FC4}" type="datetimeFigureOut">
               <a:rPr lang="en-US" smtClean="0"/>
-              <a:t>1/27/13</a:t>
+              <a:t>10/21/2026</a:t>
             </a:fld>
             <a:endParaRPr lang="en-US"/>
           </a:p>
@@ -733,10 +743,9 @@
           <a:lstStyle/>
           <a:p>
             <a:r>
-              <a:rPr lang="en-US" smtClean="0"/>
+              <a:rPr lang="en-US"/>
               <a:t>Click to edit Master title style</a:t>
             </a:r>
-            <a:endParaRPr lang="en-US"/>
           </a:p>
         </p:txBody>
       </p:sp>
@@ -757,38 +766,37 @@
           <a:p>
             <a:pPr lvl="0"/>
             <a:r>
-              <a:rPr lang="en-US" smtClean="0"/>
+              <a:rPr lang="en-US"/>
               <a:t>Click to edit Master text styles</a:t>
             </a:r>
           </a:p>
           <a:p>
             <a:pPr lvl="1"/>
             <a:r>
-              <a:rPr lang="en-US" smtClean="0"/>
+              <a:rPr lang="en-US"/>
               <a:t>Second level</a:t>
             </a:r>
           </a:p>
           <a:p>
             <a:pPr lvl="2"/>
             <a:r>
-              <a:rPr lang="en-US" smtClean="0"/>
+              <a:rPr lang="en-US"/>
               <a:t>Third level</a:t>
             </a:r>
           </a:p>
           <a:p>
             <a:pPr lvl="3"/>
             <a:r>
-              <a:rPr lang="en-US" smtClean="0"/>
+              <a:rPr lang="en-US"/>
               <a:t>Fourth level</a:t>
             </a:r>
           </a:p>
           <a:p>
             <a:pPr lvl="4"/>
             <a:r>
-              <a:rPr lang="en-US" smtClean="0"/>
+              <a:rPr lang="en-US"/>
               <a:t>Fifth level</a:t>
             </a:r>
-            <a:endParaRPr lang="en-US"/>
           </a:p>
         </p:txBody>
       </p:sp>
@@ -809,7 +817,7 @@
           <a:p>
             <a:fld id="{5BCAD085-E8A6-8845-BD4E-CB4CCA059FC4}" type="datetimeFigureOut">
               <a:rPr lang="en-US" smtClean="0"/>
-              <a:t>1/27/13</a:t>
+              <a:t>10/21/2026</a:t>
             </a:fld>
             <a:endParaRPr lang="en-US"/>
           </a:p>
@@ -912,10 +920,9 @@
           </a:lstStyle>
           <a:p>
             <a:r>
-              <a:rPr lang="en-US" smtClean="0"/>
+              <a:rPr lang="en-US"/>
               <a:t>Click to edit Master title style</a:t>
             </a:r>
-            <a:endParaRPr lang="en-US"/>
           </a:p>
         </p:txBody>
       </p:sp>
@@ -1032,7 +1039,7 @@
           <a:p>
             <a:pPr lvl="0"/>
             <a:r>
-              <a:rPr lang="en-US" smtClean="0"/>
+              <a:rPr lang="en-US"/>
               <a:t>Click to edit Master text styles</a:t>
             </a:r>
           </a:p>
@@ -1055,7 +1062,7 @@
           <a:p>
             <a:fld id="{5BCAD085-E8A6-8845-BD4E-CB4CCA059FC4}" type="datetimeFigureOut">
               <a:rPr lang="en-US" smtClean="0"/>
-              <a:t>1/27/13</a:t>
+              <a:t>10/21/2026</a:t>
             </a:fld>
             <a:endParaRPr lang="en-US"/>
           </a:p>
@@ -1149,10 +1156,9 @@
           <a:lstStyle/>
           <a:p>
             <a:r>
-              <a:rPr lang="en-US" smtClean="0"/>
+              <a:rPr lang="en-US"/>
               <a:t>Click to edit Master title style</a:t>
             </a:r>
-            <a:endParaRPr lang="en-US"/>
           </a:p>
         </p:txBody>
       </p:sp>
@@ -1206,38 +1212,37 @@
           <a:p>
             <a:pPr lvl="0"/>
             <a:r>
-              <a:rPr lang="en-US" smtClean="0"/>
+              <a:rPr lang="en-US"/>
               <a:t>Click to edit Master text styles</a:t>
             </a:r>
           </a:p>
           <a:p>
             <a:pPr lvl="1"/>
             <a:r>
-              <a:rPr lang="en-US" smtClean="0"/>
+              <a:rPr lang="en-US"/>
               <a:t>Second level</a:t>
             </a:r>
           </a:p>
           <a:p>
             <a:pPr lvl="2"/>
             <a:r>
-              <a:rPr lang="en-US" smtClean="0"/>
+              <a:rPr lang="en-US"/>
               <a:t>Third level</a:t>
             </a:r>
           </a:p>
           <a:p>
             <a:pPr lvl="3"/>
             <a:r>
-              <a:rPr lang="en-US" smtClean="0"/>
+              <a:rPr lang="en-US"/>
               <a:t>Fourth level</a:t>
             </a:r>
           </a:p>
           <a:p>
             <a:pPr lvl="4"/>
             <a:r>
-              <a:rPr lang="en-US" smtClean="0"/>
+              <a:rPr lang="en-US"/>
               <a:t>Fifth level</a:t>
             </a:r>
-            <a:endParaRPr lang="en-US"/>
           </a:p>
         </p:txBody>
       </p:sp>
@@ -1291,38 +1296,37 @@
           <a:p>
             <a:pPr lvl="0"/>
             <a:r>
-              <a:rPr lang="en-US" smtClean="0"/>
+              <a:rPr lang="en-US"/>
               <a:t>Click to edit Master text styles</a:t>
             </a:r>
           </a:p>
           <a:p>
             <a:pPr lvl="1"/>
             <a:r>
-              <a:rPr lang="en-US" smtClean="0"/>
+              <a:rPr lang="en-US"/>
               <a:t>Second level</a:t>
             </a:r>
           </a:p>
           <a:p>
             <a:pPr lvl="2"/>
             <a:r>
-              <a:rPr lang="en-US" smtClean="0"/>
+              <a:rPr lang="en-US"/>
               <a:t>Third level</a:t>
             </a:r>
           </a:p>
           <a:p>
             <a:pPr lvl="3"/>
             <a:r>
-              <a:rPr lang="en-US" smtClean="0"/>
+              <a:rPr lang="en-US"/>
               <a:t>Fourth level</a:t>
             </a:r>
           </a:p>
           <a:p>
             <a:pPr lvl="4"/>
             <a:r>
-              <a:rPr lang="en-US" smtClean="0"/>
+              <a:rPr lang="en-US"/>
               <a:t>Fifth level</a:t>
             </a:r>
-            <a:endParaRPr lang="en-US"/>
           </a:p>
         </p:txBody>
       </p:sp>
@@ -1343,7 +1347,7 @@
           <a:p>
             <a:fld id="{5BCAD085-E8A6-8845-BD4E-CB4CCA059FC4}" type="datetimeFigureOut">
               <a:rPr lang="en-US" smtClean="0"/>
-              <a:t>1/27/13</a:t>
+              <a:t>10/21/2026</a:t>
             </a:fld>
             <a:endParaRPr lang="en-US"/>
           </a:p>
@@ -1441,10 +1445,9 @@
           </a:lstStyle>
           <a:p>
             <a:r>
-              <a:rPr lang="en-US" smtClean="0"/>
+              <a:rPr lang="en-US"/>
               <a:t>Click to edit Master title style</a:t>
             </a:r>
-            <a:endParaRPr lang="en-US"/>
           </a:p>
         </p:txBody>
       </p:sp>
@@ -1507,7 +1510,7 @@
           <a:p>
             <a:pPr lvl="0"/>
             <a:r>
-              <a:rPr lang="en-US" smtClean="0"/>
+              <a:rPr lang="en-US"/>
               <a:t>Click to edit Master text styles</a:t>
             </a:r>
           </a:p>
@@ -1563,38 +1566,37 @@
           <a:p>
             <a:pPr lvl="0"/>
             <a:r>
-              <a:rPr lang="en-US" smtClean="0"/>
+              <a:rPr lang="en-US"/>
               <a:t>Click to edit Master text styles</a:t>
             </a:r>
           </a:p>
           <a:p>
             <a:pPr lvl="1"/>
             <a:r>
-              <a:rPr lang="en-US" smtClean="0"/>
+              <a:rPr lang="en-US"/>
               <a:t>Second level</a:t>
             </a:r>
           </a:p>
           <a:p>
             <a:pPr lvl="2"/>
             <a:r>
-              <a:rPr lang="en-US" smtClean="0"/>
+              <a:rPr lang="en-US"/>
               <a:t>Third level</a:t>
             </a:r>
           </a:p>
           <a:p>
             <a:pPr lvl="3"/>
             <a:r>
-              <a:rPr lang="en-US" smtClean="0"/>
+              <a:rPr lang="en-US"/>
               <a:t>Fourth level</a:t>
             </a:r>
           </a:p>
           <a:p>
             <a:pPr lvl="4"/>
             <a:r>
-              <a:rPr lang="en-US" smtClean="0"/>
+              <a:rPr lang="en-US"/>
               <a:t>Fifth level</a:t>
             </a:r>
-            <a:endParaRPr lang="en-US"/>
           </a:p>
         </p:txBody>
       </p:sp>
@@ -1657,7 +1659,7 @@
           <a:p>
             <a:pPr lvl="0"/>
             <a:r>
-              <a:rPr lang="en-US" smtClean="0"/>
+              <a:rPr lang="en-US"/>
               <a:t>Click to edit Master text styles</a:t>
             </a:r>
           </a:p>
@@ -1713,38 +1715,37 @@
           <a:p>
             <a:pPr lvl="0"/>
             <a:r>
-              <a:rPr lang="en-US" smtClean="0"/>
+              <a:rPr lang="en-US"/>
               <a:t>Click to edit Master text styles</a:t>
             </a:r>
           </a:p>
           <a:p>
             <a:pPr lvl="1"/>
             <a:r>
-              <a:rPr lang="en-US" smtClean="0"/>
+              <a:rPr lang="en-US"/>
               <a:t>Second level</a:t>
             </a:r>
           </a:p>
           <a:p>
             <a:pPr lvl="2"/>
             <a:r>
-              <a:rPr lang="en-US" smtClean="0"/>
+              <a:rPr lang="en-US"/>
               <a:t>Third level</a:t>
             </a:r>
           </a:p>
           <a:p>
             <a:pPr lvl="3"/>
             <a:r>
-              <a:rPr lang="en-US" smtClean="0"/>
+              <a:rPr lang="en-US"/>
               <a:t>Fourth level</a:t>
             </a:r>
           </a:p>
           <a:p>
             <a:pPr lvl="4"/>
             <a:r>
-              <a:rPr lang="en-US" smtClean="0"/>
+              <a:rPr lang="en-US"/>
               <a:t>Fifth level</a:t>
             </a:r>
-            <a:endParaRPr lang="en-US"/>
           </a:p>
         </p:txBody>
       </p:sp>
@@ -1765,7 +1766,7 @@
           <a:p>
             <a:fld id="{5BCAD085-E8A6-8845-BD4E-CB4CCA059FC4}" type="datetimeFigureOut">
               <a:rPr lang="en-US" smtClean="0"/>
-              <a:t>1/27/13</a:t>
+              <a:t>10/21/2026</a:t>
             </a:fld>
             <a:endParaRPr lang="en-US"/>
           </a:p>
@@ -1859,10 +1860,9 @@
           <a:lstStyle/>
           <a:p>
             <a:r>
-              <a:rPr lang="en-US" smtClean="0"/>
+              <a:rPr lang="en-US"/>
               <a:t>Click to edit Master title style</a:t>
             </a:r>
-            <a:endParaRPr lang="en-US"/>
           </a:p>
         </p:txBody>
       </p:sp>
@@ -1883,7 +1883,7 @@
           <a:p>
             <a:fld id="{5BCAD085-E8A6-8845-BD4E-CB4CCA059FC4}" type="datetimeFigureOut">
               <a:rPr lang="en-US" smtClean="0"/>
-              <a:t>1/27/13</a:t>
+              <a:t>10/21/2026</a:t>
             </a:fld>
             <a:endParaRPr lang="en-US"/>
           </a:p>
@@ -1978,7 +1978,7 @@
           <a:p>
             <a:fld id="{5BCAD085-E8A6-8845-BD4E-CB4CCA059FC4}" type="datetimeFigureOut">
               <a:rPr lang="en-US" smtClean="0"/>
-              <a:t>1/27/13</a:t>
+              <a:t>10/21/2026</a:t>
             </a:fld>
             <a:endParaRPr lang="en-US"/>
           </a:p>
@@ -2081,10 +2081,9 @@
           </a:lstStyle>
           <a:p>
             <a:r>
-              <a:rPr lang="en-US" smtClean="0"/>
+              <a:rPr lang="en-US"/>
               <a:t>Click to edit Master title style</a:t>
             </a:r>
-            <a:endParaRPr lang="en-US"/>
           </a:p>
         </p:txBody>
       </p:sp>
@@ -2138,38 +2137,37 @@
           <a:p>
             <a:pPr lvl="0"/>
             <a:r>
-              <a:rPr lang="en-US" smtClean="0"/>
+              <a:rPr lang="en-US"/>
               <a:t>Click to edit Master text styles</a:t>
             </a:r>
           </a:p>
           <a:p>
             <a:pPr lvl="1"/>
             <a:r>
-              <a:rPr lang="en-US" smtClean="0"/>
+              <a:rPr lang="en-US"/>
               <a:t>Second level</a:t>
             </a:r>
           </a:p>
           <a:p>
             <a:pPr lvl="2"/>
             <a:r>
-              <a:rPr lang="en-US" smtClean="0"/>
+              <a:rPr lang="en-US"/>
               <a:t>Third level</a:t>
             </a:r>
           </a:p>
           <a:p>
             <a:pPr lvl="3"/>
             <a:r>
-              <a:rPr lang="en-US" smtClean="0"/>
+              <a:rPr lang="en-US"/>
               <a:t>Fourth level</a:t>
             </a:r>
           </a:p>
           <a:p>
             <a:pPr lvl="4"/>
             <a:r>
-              <a:rPr lang="en-US" smtClean="0"/>
+              <a:rPr lang="en-US"/>
               <a:t>Fifth level</a:t>
             </a:r>
-            <a:endParaRPr lang="en-US"/>
           </a:p>
         </p:txBody>
       </p:sp>
@@ -2232,7 +2230,7 @@
           <a:p>
             <a:pPr lvl="0"/>
             <a:r>
-              <a:rPr lang="en-US" smtClean="0"/>
+              <a:rPr lang="en-US"/>
               <a:t>Click to edit Master text styles</a:t>
             </a:r>
           </a:p>
@@ -2255,7 +2253,7 @@
           <a:p>
             <a:fld id="{5BCAD085-E8A6-8845-BD4E-CB4CCA059FC4}" type="datetimeFigureOut">
               <a:rPr lang="en-US" smtClean="0"/>
-              <a:t>1/27/13</a:t>
+              <a:t>10/21/2026</a:t>
             </a:fld>
             <a:endParaRPr lang="en-US"/>
           </a:p>
@@ -2358,10 +2356,9 @@
           </a:lstStyle>
           <a:p>
             <a:r>
-              <a:rPr lang="en-US" smtClean="0"/>
+              <a:rPr lang="en-US"/>
               <a:t>Click to edit Master title style</a:t>
             </a:r>
-            <a:endParaRPr lang="en-US"/>
           </a:p>
         </p:txBody>
       </p:sp>
@@ -2485,7 +2482,7 @@
           <a:p>
             <a:pPr lvl="0"/>
             <a:r>
-              <a:rPr lang="en-US" smtClean="0"/>
+              <a:rPr lang="en-US"/>
               <a:t>Click to edit Master text styles</a:t>
             </a:r>
           </a:p>
@@ -2508,7 +2505,7 @@
           <a:p>
             <a:fld id="{5BCAD085-E8A6-8845-BD4E-CB4CCA059FC4}" type="datetimeFigureOut">
               <a:rPr lang="en-US" smtClean="0"/>
-              <a:t>1/27/13</a:t>
+              <a:t>10/21/2026</a:t>
             </a:fld>
             <a:endParaRPr lang="en-US"/>
           </a:p>
@@ -2617,10 +2614,9 @@
           <a:lstStyle/>
           <a:p>
             <a:r>
-              <a:rPr lang="en-US" smtClean="0"/>
+              <a:rPr lang="en-US"/>
               <a:t>Click to edit Master title style</a:t>
             </a:r>
-            <a:endParaRPr lang="en-US"/>
           </a:p>
         </p:txBody>
       </p:sp>
@@ -2651,38 +2647,37 @@
           <a:p>
             <a:pPr lvl="0"/>
             <a:r>
-              <a:rPr lang="en-US" smtClean="0"/>
+              <a:rPr lang="en-US"/>
               <a:t>Click to edit Master text styles</a:t>
             </a:r>
           </a:p>
           <a:p>
             <a:pPr lvl="1"/>
             <a:r>
-              <a:rPr lang="en-US" smtClean="0"/>
+              <a:rPr lang="en-US"/>
               <a:t>Second level</a:t>
             </a:r>
           </a:p>
           <a:p>
             <a:pPr lvl="2"/>
             <a:r>
-              <a:rPr lang="en-US" smtClean="0"/>
+              <a:rPr lang="en-US"/>
               <a:t>Third level</a:t>
             </a:r>
           </a:p>
           <a:p>
             <a:pPr lvl="3"/>
             <a:r>
-              <a:rPr lang="en-US" smtClean="0"/>
+              <a:rPr lang="en-US"/>
               <a:t>Fourth level</a:t>
             </a:r>
           </a:p>
           <a:p>
             <a:pPr lvl="4"/>
             <a:r>
-              <a:rPr lang="en-US" smtClean="0"/>
+              <a:rPr lang="en-US"/>
               <a:t>Fifth level</a:t>
             </a:r>
-            <a:endParaRPr lang="en-US"/>
           </a:p>
         </p:txBody>
       </p:sp>
@@ -2721,7 +2716,7 @@
           <a:p>
             <a:fld id="{5BCAD085-E8A6-8845-BD4E-CB4CCA059FC4}" type="datetimeFigureOut">
               <a:rPr lang="en-US" smtClean="0"/>
-              <a:t>1/27/13</a:t>
+              <a:t>10/21/2026</a:t>
             </a:fld>
             <a:endParaRPr lang="en-US"/>
           </a:p>
@@ -3080,7 +3075,7 @@
 </file>
 
 <file path=ppt/slides/slide1.xml><?xml version="1.0" encoding="utf-8"?>
-<p:sld xmlns:a="http://schemas.openxmlformats.org/drawingml/2006/main" xmlns:p="http://schemas.openxmlformats.org/presentationml/2006/main" xmlns:r="http://schemas.openxmlformats.org/officeDocument/2006/relationships">
+<p:sld xmlns:a="http://schemas.openxmlformats.org/drawingml/2006/main" xmlns:r="http://schemas.openxmlformats.org/officeDocument/2006/relationships" xmlns:p="http://schemas.openxmlformats.org/presentationml/2006/main">
   <p:cSld>
     <p:spTree>
       <p:nvGrpSpPr>
@@ -3088,7 +3083,14 @@
         <p:cNvGrpSpPr/>
         <p:nvPr/>
       </p:nvGrpSpPr>
-      <p:grpSpPr/>
+      <p:grpSpPr>
+        <a:xfrm>
+          <a:off x="0" y="0"/>
+          <a:ext cx="0" cy="0"/>
+          <a:chOff x="0" y="0"/>
+          <a:chExt cx="0" cy="0"/>
+        </a:xfrm>
+      </p:grpSpPr>
       <p:sp>
         <p:nvSpPr>
           <p:cNvPr id="2" name="TextBox 1"/>
@@ -3203,6 +3205,7 @@
           <a:lstStyle/>
           <a:p>
             <a:pPr algn="ctr"/>
+            <a:endParaRPr/>
           </a:p>
         </p:txBody>
       </p:sp>
@@ -3229,7 +3232,7 @@
           <a:lstStyle/>
           <a:p>
             <a:r>
-              <a:rPr b="1" sz="1500">
+              <a:rPr sz="1500" b="1">
                 <a:solidFill>
                   <a:srgbClr val="0F2D45"/>
                 </a:solidFill>
@@ -3362,6 +3365,7 @@
           <a:lstStyle/>
           <a:p>
             <a:pPr algn="ctr"/>
+            <a:endParaRPr/>
           </a:p>
         </p:txBody>
       </p:sp>
@@ -3478,6 +3482,7 @@
           <a:lstStyle/>
           <a:p>
             <a:pPr algn="ctr"/>
+            <a:endParaRPr/>
           </a:p>
         </p:txBody>
       </p:sp>
@@ -3594,6 +3599,7 @@
           <a:lstStyle/>
           <a:p>
             <a:pPr algn="ctr"/>
+            <a:endParaRPr/>
           </a:p>
         </p:txBody>
       </p:sp>
@@ -3710,6 +3716,7 @@
           <a:lstStyle/>
           <a:p>
             <a:pPr algn="ctr"/>
+            <a:endParaRPr/>
           </a:p>
         </p:txBody>
       </p:sp>
@@ -3792,7 +3799,7 @@
 </file>
 
 <file path=ppt/slides/slide2.xml><?xml version="1.0" encoding="utf-8"?>
-<p:sld xmlns:a="http://schemas.openxmlformats.org/drawingml/2006/main" xmlns:p="http://schemas.openxmlformats.org/presentationml/2006/main" xmlns:r="http://schemas.openxmlformats.org/officeDocument/2006/relationships">
+<p:sld xmlns:a="http://schemas.openxmlformats.org/drawingml/2006/main" xmlns:r="http://schemas.openxmlformats.org/officeDocument/2006/relationships" xmlns:p="http://schemas.openxmlformats.org/presentationml/2006/main">
   <p:cSld>
     <p:spTree>
       <p:nvGrpSpPr>
@@ -3800,7 +3807,14 @@
         <p:cNvGrpSpPr/>
         <p:nvPr/>
       </p:nvGrpSpPr>
-      <p:grpSpPr/>
+      <p:grpSpPr>
+        <a:xfrm>
+          <a:off x="0" y="0"/>
+          <a:ext cx="0" cy="0"/>
+          <a:chOff x="0" y="0"/>
+          <a:chExt cx="0" cy="0"/>
+        </a:xfrm>
+      </p:grpSpPr>
       <p:sp>
         <p:nvSpPr>
           <p:cNvPr id="2" name="TextBox 1"/>
@@ -3915,123 +3929,10 @@
           <a:lstStyle/>
           <a:p>
             <a:pPr algn="ctr"/>
-          </a:p>
-        </p:txBody>
-      </p:sp>
-      <p:sp>
-        <p:nvSpPr>
-          <p:cNvPr id="5" name="Rounded Rectangle 4"/>
-          <p:cNvSpPr/>
-          <p:nvPr/>
-        </p:nvSpPr>
-        <p:spPr>
-          <a:xfrm>
-            <a:off x="731520" y="1600200"/>
-            <a:ext cx="3108960" cy="4389120"/>
-          </a:xfrm>
-          <a:prstGeom prst="roundRect">
-            <a:avLst/>
-          </a:prstGeom>
-          <a:solidFill>
-            <a:srgbClr val="FFFFFF"/>
-          </a:solidFill>
-          <a:ln w="31750">
-            <a:solidFill>
-              <a:srgbClr val="0F2D45"/>
-            </a:solidFill>
-          </a:ln>
-        </p:spPr>
-        <p:style>
-          <a:lnRef idx="1">
-            <a:schemeClr val="accent1"/>
-          </a:lnRef>
-          <a:fillRef idx="3">
-            <a:schemeClr val="accent1"/>
-          </a:fillRef>
-          <a:effectRef idx="2">
-            <a:schemeClr val="accent1"/>
-          </a:effectRef>
-          <a:fontRef idx="minor">
-            <a:schemeClr val="lt1"/>
-          </a:fontRef>
-        </p:style>
-        <p:txBody>
-          <a:bodyPr rtlCol="0" anchor="ctr"/>
-          <a:lstStyle/>
-          <a:p>
-            <a:pPr algn="ctr"/>
-          </a:p>
-        </p:txBody>
-      </p:sp>
-      <p:sp>
-        <p:nvSpPr>
-          <p:cNvPr id="6" name="Rounded Rectangle 5"/>
-          <p:cNvSpPr/>
-          <p:nvPr/>
-        </p:nvSpPr>
-        <p:spPr>
-          <a:xfrm>
-            <a:off x="1920240" y="1719072"/>
-            <a:ext cx="731520" cy="54864"/>
-          </a:xfrm>
-          <a:prstGeom prst="roundRect">
-            <a:avLst/>
-          </a:prstGeom>
-          <a:solidFill>
-            <a:srgbClr val="B8C5D0"/>
-          </a:solidFill>
-          <a:ln>
-            <a:solidFill>
-              <a:srgbClr val="B8C5D0"/>
-            </a:solidFill>
-          </a:ln>
-        </p:spPr>
-        <p:style>
-          <a:lnRef idx="1">
-            <a:schemeClr val="accent1"/>
-          </a:lnRef>
-          <a:fillRef idx="3">
-            <a:schemeClr val="accent1"/>
-          </a:fillRef>
-          <a:effectRef idx="2">
-            <a:schemeClr val="accent1"/>
-          </a:effectRef>
-          <a:fontRef idx="minor">
-            <a:schemeClr val="lt1"/>
-          </a:fontRef>
-        </p:style>
-        <p:txBody>
-          <a:bodyPr rtlCol="0" anchor="ctr"/>
-          <a:lstStyle/>
-          <a:p>
-            <a:pPr algn="ctr"/>
-          </a:p>
-        </p:txBody>
-      </p:sp>
-      <p:pic>
-        <p:nvPicPr>
-          <p:cNvPr id="7" name="Picture 6" descr="site_phone_screen.png"/>
-          <p:cNvPicPr>
-            <a:picLocks noChangeAspect="1"/>
-          </p:cNvPicPr>
-          <p:nvPr/>
-        </p:nvPicPr>
-        <p:blipFill>
-          <a:blip r:embed="rId2"/>
-          <a:stretch>
-            <a:fillRect/>
-          </a:stretch>
-        </p:blipFill>
-        <p:spPr>
-          <a:xfrm>
-            <a:off x="868680" y="1847088"/>
-            <a:ext cx="2834640" cy="4023360"/>
-          </a:xfrm>
-          <a:prstGeom prst="rect">
-            <a:avLst/>
-          </a:prstGeom>
-        </p:spPr>
-      </p:pic>
+            <a:endParaRPr/>
+          </a:p>
+        </p:txBody>
+      </p:sp>
       <p:sp>
         <p:nvSpPr>
           <p:cNvPr id="8" name="TextBox 7"/>
@@ -4075,8 +3976,8 @@
         </p:nvSpPr>
         <p:spPr>
           <a:xfrm>
-            <a:off x="4206240" y="1600200"/>
-            <a:ext cx="7223760" cy="4297680"/>
+            <a:off x="6096000" y="1691640"/>
+            <a:ext cx="5475567" cy="3257302"/>
           </a:xfrm>
           <a:prstGeom prst="rect">
             <a:avLst/>
@@ -4101,6 +4002,7 @@
               </a:defRPr>
             </a:pPr>
             <a:r>
+              <a:rPr dirty="0"/>
               <a:t>PROTOTYPE FOCUS</a:t>
             </a:r>
           </a:p>
@@ -4117,6 +4019,7 @@
               </a:defRPr>
             </a:pPr>
             <a:r>
+              <a:rPr dirty="0"/>
               <a:t>•  Simple navigation and prominent, high-contrast primary actions</a:t>
             </a:r>
           </a:p>
@@ -4133,6 +4036,7 @@
               </a:defRPr>
             </a:pPr>
             <a:r>
+              <a:rPr dirty="0"/>
               <a:t>•  Clear pathways to physical assistance, barrier reporting, and accessible facilities</a:t>
             </a:r>
           </a:p>
@@ -4149,6 +4053,7 @@
               </a:defRPr>
             </a:pPr>
             <a:r>
+              <a:rPr dirty="0"/>
               <a:t>•  Mobile-friendly, responsive layout adhering strictly to WCAG touch standards (44px+)</a:t>
             </a:r>
           </a:p>
@@ -4165,6 +4070,7 @@
               </a:defRPr>
             </a:pPr>
             <a:r>
+              <a:rPr dirty="0"/>
               <a:t>•  Short, accessible labels paired with assistive screen-reader and voice support</a:t>
             </a:r>
           </a:p>
@@ -4181,6 +4087,7 @@
               </a:defRPr>
             </a:pPr>
             <a:r>
+              <a:rPr dirty="0"/>
               <a:t>•  Guides users toward a clear, friction-free next step with zero cognitive overload</a:t>
             </a:r>
           </a:p>
@@ -4197,6 +4104,7 @@
               </a:defRPr>
             </a:pPr>
             <a:r>
+              <a:rPr dirty="0"/>
               <a:t>•  Live volunteer dispatcher with Leaflet.js interactive maps and verified NSS student profiles</a:t>
             </a:r>
           </a:p>
@@ -4244,6 +4152,7 @@
           <a:lstStyle/>
           <a:p>
             <a:pPr algn="ctr"/>
+            <a:endParaRPr/>
           </a:p>
         </p:txBody>
       </p:sp>
@@ -4317,6 +4226,37 @@
           </a:p>
         </p:txBody>
       </p:sp>
+      <p:pic>
+        <p:nvPicPr>
+          <p:cNvPr id="14" name="Picture 13">
+            <a:extLst>
+              <a:ext uri="{FF2B5EF4-FFF2-40B4-BE49-F238E27FC236}">
+                <a16:creationId xmlns:a16="http://schemas.microsoft.com/office/drawing/2014/main" id="{0CEAEB93-4359-F923-F1BE-B2DBEC7F2464}"/>
+              </a:ext>
+            </a:extLst>
+          </p:cNvPr>
+          <p:cNvPicPr>
+            <a:picLocks noChangeAspect="1"/>
+          </p:cNvPicPr>
+          <p:nvPr/>
+        </p:nvPicPr>
+        <p:blipFill>
+          <a:blip r:embed="rId2"/>
+          <a:srcRect l="8152" r="2025"/>
+          <a:stretch>
+            <a:fillRect/>
+          </a:stretch>
+        </p:blipFill>
+        <p:spPr>
+          <a:xfrm>
+            <a:off x="279057" y="1746504"/>
+            <a:ext cx="5675375" cy="3220726"/>
+          </a:xfrm>
+          <a:prstGeom prst="rect">
+            <a:avLst/>
+          </a:prstGeom>
+        </p:spPr>
+      </p:pic>
     </p:spTree>
   </p:cSld>
   <p:clrMapOvr>

</xml_diff>